<commit_message>
Thesis: plainer wording in the introduction, results, discussion and conclusion; PDF title and author metadata. Deck: co-guide on the title slide, plainer final takeaway
</commit_message>
<xml_diff>
--- a/presentation/CardioCog_final_review_D07.pptx
+++ b/presentation/CardioCog_final_review_D07.pptx
@@ -3272,6 +3272,23 @@
           <a:p>
             <a:pPr marL="0" indent="0" algn="ctr">
               <a:spcAft>
+                <a:spcPts val="400"/>
+              </a:spcAft>
+              <a:buNone/>
+            </a:pPr>
+            <a:r>
+              <a:rPr sz="1400" b="0">
+                <a:solidFill>
+                  <a:srgbClr val="595959"/>
+                </a:solidFill>
+                <a:latin typeface="Calibri"/>
+              </a:rPr>
+              <a:t>Team D07</a:t>
+            </a:r>
+          </a:p>
+          <a:p>
+            <a:pPr marL="0" indent="0" algn="ctr">
+              <a:spcAft>
                 <a:spcPts val="0"/>
               </a:spcAft>
               <a:buNone/>
@@ -3283,7 +3300,7 @@
                 </a:solidFill>
                 <a:latin typeface="Calibri"/>
               </a:rPr>
-              <a:t>Team D07  |  Supervisor: Dr. Manoj Bhat K, Professor</a:t>
+              <a:t>Guide: Dr. Manoj Bhat K, Professor  |  Co-guide: Amrutha Veluppal, Professor</a:t>
             </a:r>
           </a:p>
         </p:txBody>
@@ -19418,7 +19435,7 @@
                 </a:solidFill>
                 <a:latin typeface="Calibri"/>
               </a:rPr>
-              <a:t>How a person is functioning today carries most of the three-year signal; vascular and genetic history leave their trace in that measurement rather than adding to it.</a:t>
+              <a:t>Current cognitive and functional status carries most of the three-year signal; vascular and genetic history add little once it is known.</a:t>
             </a:r>
           </a:p>
         </p:txBody>

</xml_diff>